<commit_message>
Link public submission artifacts and finalize presentation notes
</commit_message>
<xml_diff>
--- a/submission/TechTitan_presentation_agentic.pptx
+++ b/submission/TechTitan_presentation_agentic.pptx
@@ -2,22 +2,22 @@
 <file path=ppt/presentation.xml><?xml version="1.0" encoding="utf-8"?>
 <p:presentation xmlns:p="http://schemas.openxmlformats.org/presentationml/2006/main">
   <p:sldMasterIdLst>
-    <p:sldMasterId xmlns:r="http://schemas.openxmlformats.org/officeDocument/2006/relationships" id="2147483648" r:id="R8241ed0189ce4456"/>
+    <p:sldMasterId xmlns:r="http://schemas.openxmlformats.org/officeDocument/2006/relationships" id="2147483648" r:id="R2ef09eb1de554e04"/>
   </p:sldMasterIdLst>
   <p:notesMasterIdLst>
-    <p:notesMasterId xmlns:r="http://schemas.openxmlformats.org/officeDocument/2006/relationships" r:id="R7ae98450ecd147ac"/>
+    <p:notesMasterId xmlns:r="http://schemas.openxmlformats.org/officeDocument/2006/relationships" r:id="R3be76c3f6dd04853"/>
   </p:notesMasterIdLst>
   <p:sldIdLst>
-    <p:sldId xmlns:r="http://schemas.openxmlformats.org/officeDocument/2006/relationships" id="256" r:id="R4fa32374ed4f4981"/>
-    <p:sldId xmlns:r="http://schemas.openxmlformats.org/officeDocument/2006/relationships" id="257" r:id="R9ca0e822f6844cab"/>
-    <p:sldId xmlns:r="http://schemas.openxmlformats.org/officeDocument/2006/relationships" id="258" r:id="Rac0f2d6998f0445a"/>
-    <p:sldId xmlns:r="http://schemas.openxmlformats.org/officeDocument/2006/relationships" id="259" r:id="R3ff109b6cfb24ce5"/>
-    <p:sldId xmlns:r="http://schemas.openxmlformats.org/officeDocument/2006/relationships" id="260" r:id="R6f52bdce71e147c5"/>
-    <p:sldId xmlns:r="http://schemas.openxmlformats.org/officeDocument/2006/relationships" id="261" r:id="R3dea869700d74cb9"/>
-    <p:sldId xmlns:r="http://schemas.openxmlformats.org/officeDocument/2006/relationships" id="262" r:id="Ra08fdc6f91464952"/>
-    <p:sldId xmlns:r="http://schemas.openxmlformats.org/officeDocument/2006/relationships" id="263" r:id="R0f1fa893cd4546ca"/>
-    <p:sldId xmlns:r="http://schemas.openxmlformats.org/officeDocument/2006/relationships" id="264" r:id="R95af3d2b92d4496f"/>
-    <p:sldId xmlns:r="http://schemas.openxmlformats.org/officeDocument/2006/relationships" id="265" r:id="R27a417ef19ed4f74"/>
+    <p:sldId xmlns:r="http://schemas.openxmlformats.org/officeDocument/2006/relationships" id="256" r:id="Re3d6bffdd55e44e9"/>
+    <p:sldId xmlns:r="http://schemas.openxmlformats.org/officeDocument/2006/relationships" id="257" r:id="Ra62e9889429b4d9a"/>
+    <p:sldId xmlns:r="http://schemas.openxmlformats.org/officeDocument/2006/relationships" id="258" r:id="Rd4b3611f15ef4f31"/>
+    <p:sldId xmlns:r="http://schemas.openxmlformats.org/officeDocument/2006/relationships" id="259" r:id="Rdbd001a6d676491a"/>
+    <p:sldId xmlns:r="http://schemas.openxmlformats.org/officeDocument/2006/relationships" id="260" r:id="R067f28a22b5540e6"/>
+    <p:sldId xmlns:r="http://schemas.openxmlformats.org/officeDocument/2006/relationships" id="261" r:id="R0d6a1b2500a94cc7"/>
+    <p:sldId xmlns:r="http://schemas.openxmlformats.org/officeDocument/2006/relationships" id="262" r:id="R0b6e595d0e9241a3"/>
+    <p:sldId xmlns:r="http://schemas.openxmlformats.org/officeDocument/2006/relationships" id="263" r:id="Rd1714d40bb234d87"/>
+    <p:sldId xmlns:r="http://schemas.openxmlformats.org/officeDocument/2006/relationships" id="264" r:id="R661d9097099349bd"/>
+    <p:sldId xmlns:r="http://schemas.openxmlformats.org/officeDocument/2006/relationships" id="265" r:id="R8c2c90e8550d4e23"/>
   </p:sldIdLst>
   <p:sldSz cx="12192000" cy="6858000"/>
   <p:notesSz cx="6858000" cy="9144000"/>
@@ -531,7 +531,7 @@
           <a:lstStyle xmlns:a="http://schemas.openxmlformats.org/drawingml/2006/main"/>
           <a:p xmlns:a="http://schemas.openxmlformats.org/drawingml/2006/main">
             <a:r>
-              <a:t>Problem 6 was selected because the entire sandbox and objective verification can be built with owned synthetic data. No qualification or business-performance guarantee is made. Public repository publication remains a team submission step.</a:t>
+              <a:t>Problem 6 was selected because the entire sandbox and objective verification can be built with owned synthetic data. No qualification or business-performance guarantee is made. Public source and deliverables: https://github.com/realgauravvyas/TechTitan-RouteGuard-Agentic</a:t>
             </a:r>
           </a:p>
           <a:p xmlns:a="http://schemas.openxmlformats.org/drawingml/2006/main">
@@ -1249,7 +1249,7 @@
   </p:cSld>
   <p:clrMap bg1="lt1" tx1="dk1" bg2="lt2" tx2="dk2" accent1="accent1" accent2="accent2" accent3="accent3" accent4="accent4" accent5="accent5" accent6="accent6" hlink="hlink" folHlink="folHlink"/>
   <p:sldLayoutIdLst>
-    <p:sldLayoutId xmlns:r="http://schemas.openxmlformats.org/officeDocument/2006/relationships" id="2147483649" r:id="R11a6d33a28d845df"/>
+    <p:sldLayoutId xmlns:r="http://schemas.openxmlformats.org/officeDocument/2006/relationships" id="2147483649" r:id="R694cc7d1e1284d27"/>
   </p:sldLayoutIdLst>
   <p:txStyles>
     <p:titleStyle>
@@ -1800,7 +1800,7 @@
           <p:cNvPr id="6" name="">
             <a:extLst xmlns:a="http://schemas.openxmlformats.org/drawingml/2006/main">
               <a:ext uri="{FF2B5EF4-FFF2-40B4-BE49-F238E27FC236}">
-                <a16:creationId xmlns:a16="http://schemas.microsoft.com/office/drawing/2014/main" id="{07BEA3B7-FF45-43E3-9D0B-30DE4A85B33A}"/>
+                <a16:creationId xmlns:a16="http://schemas.microsoft.com/office/drawing/2014/main" id="{99ED812B-7059-49BD-A570-62B09A4CC695}"/>
               </a:ext>
             </a:extLst>
           </p:cNvPr>
@@ -1857,7 +1857,7 @@
           <p:cNvPr id="2" name="">
             <a:extLst xmlns:a="http://schemas.openxmlformats.org/drawingml/2006/main">
               <a:ext uri="{FF2B5EF4-FFF2-40B4-BE49-F238E27FC236}">
-                <a16:creationId xmlns:a16="http://schemas.microsoft.com/office/drawing/2014/main" id="{B8A8E720-3550-4E08-A1DC-B0F4978D71E6}"/>
+                <a16:creationId xmlns:a16="http://schemas.microsoft.com/office/drawing/2014/main" id="{75C5A57D-2E94-4CCC-866C-68192155C77B}"/>
               </a:ext>
             </a:extLst>
           </p:cNvPr>
@@ -1914,7 +1914,7 @@
           <p:cNvPr id="3" name="">
             <a:extLst xmlns:a="http://schemas.openxmlformats.org/drawingml/2006/main">
               <a:ext uri="{FF2B5EF4-FFF2-40B4-BE49-F238E27FC236}">
-                <a16:creationId xmlns:a16="http://schemas.microsoft.com/office/drawing/2014/main" id="{912EBF51-777F-41FE-928A-A4272CD9B216}"/>
+                <a16:creationId xmlns:a16="http://schemas.microsoft.com/office/drawing/2014/main" id="{BEE2113F-8287-40F3-A02F-9D155E2D4E0D}"/>
               </a:ext>
             </a:extLst>
           </p:cNvPr>
@@ -1971,7 +1971,7 @@
           <p:cNvPr id="4" name="">
             <a:extLst xmlns:a="http://schemas.openxmlformats.org/drawingml/2006/main">
               <a:ext uri="{FF2B5EF4-FFF2-40B4-BE49-F238E27FC236}">
-                <a16:creationId xmlns:a16="http://schemas.microsoft.com/office/drawing/2014/main" id="{40B61FE2-258E-4B43-98C9-3F83B98F56CA}"/>
+                <a16:creationId xmlns:a16="http://schemas.microsoft.com/office/drawing/2014/main" id="{C74382EF-2087-4D3A-82FB-EE013A08E7C3}"/>
               </a:ext>
             </a:extLst>
           </p:cNvPr>
@@ -2051,7 +2051,7 @@
           <p:cNvPr id="5" name="">
             <a:extLst xmlns:a="http://schemas.openxmlformats.org/drawingml/2006/main">
               <a:ext uri="{FF2B5EF4-FFF2-40B4-BE49-F238E27FC236}">
-                <a16:creationId xmlns:a16="http://schemas.microsoft.com/office/drawing/2014/main" id="{FC011A15-6DCC-4D16-8D71-0153128E2AC8}"/>
+                <a16:creationId xmlns:a16="http://schemas.microsoft.com/office/drawing/2014/main" id="{D4785739-1831-415A-865D-005E3E5AA32B}"/>
               </a:ext>
             </a:extLst>
           </p:cNvPr>
@@ -2106,7 +2106,7 @@
     </p:spTree>
     <p:extLst>
       <p:ext uri="{BB962C8B-B14F-4D97-AF65-F5344CB8AC3E}">
-        <p14:creationId xmlns:p14="http://schemas.microsoft.com/office/powerpoint/2010/main" val="879710881"/>
+        <p14:creationId xmlns:p14="http://schemas.microsoft.com/office/powerpoint/2010/main" val="587987628"/>
       </p:ext>
     </p:extLst>
   </p:cSld>
@@ -2137,7 +2137,7 @@
           <p:cNvPr id="7" name="">
             <a:extLst xmlns:a="http://schemas.openxmlformats.org/drawingml/2006/main">
               <a:ext uri="{FF2B5EF4-FFF2-40B4-BE49-F238E27FC236}">
-                <a16:creationId xmlns:a16="http://schemas.microsoft.com/office/drawing/2014/main" id="{7220A226-8E0B-4619-9729-6B216674436C}"/>
+                <a16:creationId xmlns:a16="http://schemas.microsoft.com/office/drawing/2014/main" id="{37352960-7E78-4327-90F3-F198B0A92F7C}"/>
               </a:ext>
             </a:extLst>
           </p:cNvPr>
@@ -2194,7 +2194,7 @@
           <p:cNvPr id="2" name="">
             <a:extLst xmlns:a="http://schemas.openxmlformats.org/drawingml/2006/main">
               <a:ext uri="{FF2B5EF4-FFF2-40B4-BE49-F238E27FC236}">
-                <a16:creationId xmlns:a16="http://schemas.microsoft.com/office/drawing/2014/main" id="{98C95B1A-3949-4995-A9D6-19FE8627AC11}"/>
+                <a16:creationId xmlns:a16="http://schemas.microsoft.com/office/drawing/2014/main" id="{4979F4BD-067D-43A1-A726-2B76F14C57B8}"/>
               </a:ext>
             </a:extLst>
           </p:cNvPr>
@@ -2251,7 +2251,7 @@
           <p:cNvPr id="3" name="">
             <a:extLst xmlns:a="http://schemas.openxmlformats.org/drawingml/2006/main">
               <a:ext uri="{FF2B5EF4-FFF2-40B4-BE49-F238E27FC236}">
-                <a16:creationId xmlns:a16="http://schemas.microsoft.com/office/drawing/2014/main" id="{11C18213-D4E9-4911-AFDF-4163B1EDCACE}"/>
+                <a16:creationId xmlns:a16="http://schemas.microsoft.com/office/drawing/2014/main" id="{91A36255-DBFB-4819-B793-AD97EB61EB88}"/>
               </a:ext>
             </a:extLst>
           </p:cNvPr>
@@ -2308,7 +2308,7 @@
           <p:cNvPr id="4" name="">
             <a:extLst xmlns:a="http://schemas.openxmlformats.org/drawingml/2006/main">
               <a:ext uri="{FF2B5EF4-FFF2-40B4-BE49-F238E27FC236}">
-                <a16:creationId xmlns:a16="http://schemas.microsoft.com/office/drawing/2014/main" id="{805452C3-01A5-457C-81CF-9D7757E449B0}"/>
+                <a16:creationId xmlns:a16="http://schemas.microsoft.com/office/drawing/2014/main" id="{0400B3AB-87D0-4987-83BE-F850396AA81A}"/>
               </a:ext>
             </a:extLst>
           </p:cNvPr>
@@ -2388,7 +2388,7 @@
           <p:cNvPr id="5" name="">
             <a:extLst xmlns:a="http://schemas.openxmlformats.org/drawingml/2006/main">
               <a:ext uri="{FF2B5EF4-FFF2-40B4-BE49-F238E27FC236}">
-                <a16:creationId xmlns:a16="http://schemas.microsoft.com/office/drawing/2014/main" id="{E8966C10-110A-469C-A78B-72745CD4BD68}"/>
+                <a16:creationId xmlns:a16="http://schemas.microsoft.com/office/drawing/2014/main" id="{E65B9DD0-EDEE-429E-958B-BDC49D71E531}"/>
               </a:ext>
             </a:extLst>
           </p:cNvPr>
@@ -2468,7 +2468,7 @@
           <p:cNvPr id="6" name="">
             <a:extLst xmlns:a="http://schemas.openxmlformats.org/drawingml/2006/main">
               <a:ext uri="{FF2B5EF4-FFF2-40B4-BE49-F238E27FC236}">
-                <a16:creationId xmlns:a16="http://schemas.microsoft.com/office/drawing/2014/main" id="{7D054A02-6F85-4318-B403-E6103ACFB73A}"/>
+                <a16:creationId xmlns:a16="http://schemas.microsoft.com/office/drawing/2014/main" id="{1C8392C1-B8A2-40AF-A40F-AACE4A34296A}"/>
               </a:ext>
             </a:extLst>
           </p:cNvPr>
@@ -2523,7 +2523,7 @@
     </p:spTree>
     <p:extLst>
       <p:ext uri="{BB962C8B-B14F-4D97-AF65-F5344CB8AC3E}">
-        <p14:creationId xmlns:p14="http://schemas.microsoft.com/office/powerpoint/2010/main" val="745529270"/>
+        <p14:creationId xmlns:p14="http://schemas.microsoft.com/office/powerpoint/2010/main" val="1732470432"/>
       </p:ext>
     </p:extLst>
   </p:cSld>
@@ -2554,7 +2554,7 @@
           <p:cNvPr id="9" name="">
             <a:extLst xmlns:a="http://schemas.openxmlformats.org/drawingml/2006/main">
               <a:ext uri="{FF2B5EF4-FFF2-40B4-BE49-F238E27FC236}">
-                <a16:creationId xmlns:a16="http://schemas.microsoft.com/office/drawing/2014/main" id="{31510221-79DA-47D4-9AD3-4EBE5EE430F1}"/>
+                <a16:creationId xmlns:a16="http://schemas.microsoft.com/office/drawing/2014/main" id="{88314E51-A9A5-426C-9857-7CA0E3D5B4F3}"/>
               </a:ext>
             </a:extLst>
           </p:cNvPr>
@@ -2611,7 +2611,7 @@
           <p:cNvPr id="2" name="">
             <a:extLst xmlns:a="http://schemas.openxmlformats.org/drawingml/2006/main">
               <a:ext uri="{FF2B5EF4-FFF2-40B4-BE49-F238E27FC236}">
-                <a16:creationId xmlns:a16="http://schemas.microsoft.com/office/drawing/2014/main" id="{3110263E-F92F-4018-9395-DDE836EF0D27}"/>
+                <a16:creationId xmlns:a16="http://schemas.microsoft.com/office/drawing/2014/main" id="{BEB1006B-7E64-4BDB-B002-34B0184D15CF}"/>
               </a:ext>
             </a:extLst>
           </p:cNvPr>
@@ -2668,7 +2668,7 @@
           <p:cNvPr id="3" name="">
             <a:extLst xmlns:a="http://schemas.openxmlformats.org/drawingml/2006/main">
               <a:ext uri="{FF2B5EF4-FFF2-40B4-BE49-F238E27FC236}">
-                <a16:creationId xmlns:a16="http://schemas.microsoft.com/office/drawing/2014/main" id="{49A59010-7A7B-4B5E-9DAE-6A8BA336DDCF}"/>
+                <a16:creationId xmlns:a16="http://schemas.microsoft.com/office/drawing/2014/main" id="{95D97A81-08CB-49EC-9E39-43FC88FF12D5}"/>
               </a:ext>
             </a:extLst>
           </p:cNvPr>
@@ -2725,7 +2725,7 @@
           <p:cNvPr id="4" name="">
             <a:extLst xmlns:a="http://schemas.openxmlformats.org/drawingml/2006/main">
               <a:ext uri="{FF2B5EF4-FFF2-40B4-BE49-F238E27FC236}">
-                <a16:creationId xmlns:a16="http://schemas.microsoft.com/office/drawing/2014/main" id="{46A71EAA-0CD3-4A92-B4DF-95D5D30CD2DD}"/>
+                <a16:creationId xmlns:a16="http://schemas.microsoft.com/office/drawing/2014/main" id="{EA4A43A8-672C-4BC1-A6F1-390EAD163DC5}"/>
               </a:ext>
             </a:extLst>
           </p:cNvPr>
@@ -2782,7 +2782,7 @@
           <p:cNvPr id="5" name="">
             <a:extLst xmlns:a="http://schemas.openxmlformats.org/drawingml/2006/main">
               <a:ext uri="{FF2B5EF4-FFF2-40B4-BE49-F238E27FC236}">
-                <a16:creationId xmlns:a16="http://schemas.microsoft.com/office/drawing/2014/main" id="{1CECE614-92F2-474B-ABF5-F7C5C1D9D20D}"/>
+                <a16:creationId xmlns:a16="http://schemas.microsoft.com/office/drawing/2014/main" id="{8D5AC2E4-DFAE-41F3-A2A5-9E598334E958}"/>
               </a:ext>
             </a:extLst>
           </p:cNvPr>
@@ -2839,7 +2839,7 @@
           <p:cNvPr id="6" name="">
             <a:extLst xmlns:a="http://schemas.openxmlformats.org/drawingml/2006/main">
               <a:ext uri="{FF2B5EF4-FFF2-40B4-BE49-F238E27FC236}">
-                <a16:creationId xmlns:a16="http://schemas.microsoft.com/office/drawing/2014/main" id="{1C51F71F-3AC6-4769-AC9C-802F7B414E77}"/>
+                <a16:creationId xmlns:a16="http://schemas.microsoft.com/office/drawing/2014/main" id="{F8A86BB0-6F18-46A5-9553-35C10349EDA3}"/>
               </a:ext>
             </a:extLst>
           </p:cNvPr>
@@ -2942,7 +2942,7 @@
           <p:cNvPr id="7" name="">
             <a:extLst xmlns:a="http://schemas.openxmlformats.org/drawingml/2006/main">
               <a:ext uri="{FF2B5EF4-FFF2-40B4-BE49-F238E27FC236}">
-                <a16:creationId xmlns:a16="http://schemas.microsoft.com/office/drawing/2014/main" id="{8FDA88FE-7864-4390-962E-E6BEDE5FB3C0}"/>
+                <a16:creationId xmlns:a16="http://schemas.microsoft.com/office/drawing/2014/main" id="{9478C2C6-183A-4C22-976F-CCA3DC4FCD07}"/>
               </a:ext>
             </a:extLst>
           </p:cNvPr>
@@ -2999,7 +2999,7 @@
           <p:cNvPr id="8" name="">
             <a:extLst xmlns:a="http://schemas.openxmlformats.org/drawingml/2006/main">
               <a:ext uri="{FF2B5EF4-FFF2-40B4-BE49-F238E27FC236}">
-                <a16:creationId xmlns:a16="http://schemas.microsoft.com/office/drawing/2014/main" id="{577837B7-1FED-4BE5-BB32-170F5A1E4D5D}"/>
+                <a16:creationId xmlns:a16="http://schemas.microsoft.com/office/drawing/2014/main" id="{84214979-53BC-4618-8C7B-B425123E0195}"/>
               </a:ext>
             </a:extLst>
           </p:cNvPr>
@@ -3054,7 +3054,7 @@
     </p:spTree>
     <p:extLst>
       <p:ext uri="{BB962C8B-B14F-4D97-AF65-F5344CB8AC3E}">
-        <p14:creationId xmlns:p14="http://schemas.microsoft.com/office/powerpoint/2010/main" val="432861252"/>
+        <p14:creationId xmlns:p14="http://schemas.microsoft.com/office/powerpoint/2010/main" val="2027379442"/>
       </p:ext>
     </p:extLst>
   </p:cSld>
@@ -3085,7 +3085,7 @@
           <p:cNvPr id="13" name="">
             <a:extLst xmlns:a="http://schemas.openxmlformats.org/drawingml/2006/main">
               <a:ext uri="{FF2B5EF4-FFF2-40B4-BE49-F238E27FC236}">
-                <a16:creationId xmlns:a16="http://schemas.microsoft.com/office/drawing/2014/main" id="{72E3CA34-F764-4E37-A200-FEA8A2A7E1D1}"/>
+                <a16:creationId xmlns:a16="http://schemas.microsoft.com/office/drawing/2014/main" id="{2855EB98-6A77-4EA5-B444-3B033B2EC93B}"/>
               </a:ext>
             </a:extLst>
           </p:cNvPr>
@@ -3142,7 +3142,7 @@
           <p:cNvPr id="2" name="">
             <a:extLst xmlns:a="http://schemas.openxmlformats.org/drawingml/2006/main">
               <a:ext uri="{FF2B5EF4-FFF2-40B4-BE49-F238E27FC236}">
-                <a16:creationId xmlns:a16="http://schemas.microsoft.com/office/drawing/2014/main" id="{34B63C20-6357-4399-AB6D-BC49D7721428}"/>
+                <a16:creationId xmlns:a16="http://schemas.microsoft.com/office/drawing/2014/main" id="{B6BEA0C5-C0DC-409C-8CC9-77C5A2D0F454}"/>
               </a:ext>
             </a:extLst>
           </p:cNvPr>
@@ -3199,7 +3199,7 @@
           <p:cNvPr id="3" name="">
             <a:extLst xmlns:a="http://schemas.openxmlformats.org/drawingml/2006/main">
               <a:ext uri="{FF2B5EF4-FFF2-40B4-BE49-F238E27FC236}">
-                <a16:creationId xmlns:a16="http://schemas.microsoft.com/office/drawing/2014/main" id="{BDCF4F28-9E70-4202-8550-653001017E4A}"/>
+                <a16:creationId xmlns:a16="http://schemas.microsoft.com/office/drawing/2014/main" id="{4795BF5D-5981-4CFA-B5AD-C94F8FA03972}"/>
               </a:ext>
             </a:extLst>
           </p:cNvPr>
@@ -3256,7 +3256,7 @@
           <p:cNvPr id="4" name="">
             <a:extLst xmlns:a="http://schemas.openxmlformats.org/drawingml/2006/main">
               <a:ext uri="{FF2B5EF4-FFF2-40B4-BE49-F238E27FC236}">
-                <a16:creationId xmlns:a16="http://schemas.microsoft.com/office/drawing/2014/main" id="{124337EE-8264-4DF2-9227-DA7DA125EC43}"/>
+                <a16:creationId xmlns:a16="http://schemas.microsoft.com/office/drawing/2014/main" id="{F25B595A-3536-4E61-AEB7-716D38F7975D}"/>
               </a:ext>
             </a:extLst>
           </p:cNvPr>
@@ -3338,7 +3338,7 @@
           <p:cNvPr id="5" name="">
             <a:extLst xmlns:a="http://schemas.openxmlformats.org/drawingml/2006/main">
               <a:ext uri="{FF2B5EF4-FFF2-40B4-BE49-F238E27FC236}">
-                <a16:creationId xmlns:a16="http://schemas.microsoft.com/office/drawing/2014/main" id="{3FF16BF8-B23C-48FD-94C0-DF5711DF589A}"/>
+                <a16:creationId xmlns:a16="http://schemas.microsoft.com/office/drawing/2014/main" id="{FEF2B006-CE36-41FB-A95A-374092322714}"/>
               </a:ext>
             </a:extLst>
           </p:cNvPr>
@@ -3420,7 +3420,7 @@
           <p:cNvPr id="6" name="">
             <a:extLst xmlns:a="http://schemas.openxmlformats.org/drawingml/2006/main">
               <a:ext uri="{FF2B5EF4-FFF2-40B4-BE49-F238E27FC236}">
-                <a16:creationId xmlns:a16="http://schemas.microsoft.com/office/drawing/2014/main" id="{1375A021-DD8A-4FD7-9C81-45718DECC3A3}"/>
+                <a16:creationId xmlns:a16="http://schemas.microsoft.com/office/drawing/2014/main" id="{A1AA291A-F69F-4B09-87CC-D1E414196C13}"/>
               </a:ext>
             </a:extLst>
           </p:cNvPr>
@@ -3502,7 +3502,7 @@
           <p:cNvPr id="7" name="">
             <a:extLst xmlns:a="http://schemas.openxmlformats.org/drawingml/2006/main">
               <a:ext uri="{FF2B5EF4-FFF2-40B4-BE49-F238E27FC236}">
-                <a16:creationId xmlns:a16="http://schemas.microsoft.com/office/drawing/2014/main" id="{B27F5DE5-0AD9-4FE3-B901-FC57CF825AD7}"/>
+                <a16:creationId xmlns:a16="http://schemas.microsoft.com/office/drawing/2014/main" id="{02355794-6406-48DC-AC32-454A8CFED2A2}"/>
               </a:ext>
             </a:extLst>
           </p:cNvPr>
@@ -3659,7 +3659,7 @@
           <p:cNvPr id="11" name="">
             <a:extLst xmlns:a="http://schemas.openxmlformats.org/drawingml/2006/main">
               <a:ext uri="{FF2B5EF4-FFF2-40B4-BE49-F238E27FC236}">
-                <a16:creationId xmlns:a16="http://schemas.microsoft.com/office/drawing/2014/main" id="{DD4E74A1-C543-48B9-9A24-4330BE093EFD}"/>
+                <a16:creationId xmlns:a16="http://schemas.microsoft.com/office/drawing/2014/main" id="{AACA066D-C7B1-4B0D-9FE7-39142F4C10FD}"/>
               </a:ext>
             </a:extLst>
           </p:cNvPr>
@@ -3716,7 +3716,7 @@
           <p:cNvPr id="12" name="">
             <a:extLst xmlns:a="http://schemas.openxmlformats.org/drawingml/2006/main">
               <a:ext uri="{FF2B5EF4-FFF2-40B4-BE49-F238E27FC236}">
-                <a16:creationId xmlns:a16="http://schemas.microsoft.com/office/drawing/2014/main" id="{EA1424A1-A04C-479D-A800-65F5BA8882D1}"/>
+                <a16:creationId xmlns:a16="http://schemas.microsoft.com/office/drawing/2014/main" id="{9624EF72-1845-4B83-B4BE-1CDFF4B1AC14}"/>
               </a:ext>
             </a:extLst>
           </p:cNvPr>
@@ -3771,7 +3771,7 @@
     </p:spTree>
     <p:extLst>
       <p:ext uri="{BB962C8B-B14F-4D97-AF65-F5344CB8AC3E}">
-        <p14:creationId xmlns:p14="http://schemas.microsoft.com/office/powerpoint/2010/main" val="1897050552"/>
+        <p14:creationId xmlns:p14="http://schemas.microsoft.com/office/powerpoint/2010/main" val="1144430655"/>
       </p:ext>
     </p:extLst>
   </p:cSld>
@@ -3802,7 +3802,7 @@
           <p:cNvPr id="18" name="">
             <a:extLst xmlns:a="http://schemas.openxmlformats.org/drawingml/2006/main">
               <a:ext uri="{FF2B5EF4-FFF2-40B4-BE49-F238E27FC236}">
-                <a16:creationId xmlns:a16="http://schemas.microsoft.com/office/drawing/2014/main" id="{E2075543-62A2-4DCD-83D1-271368F12C79}"/>
+                <a16:creationId xmlns:a16="http://schemas.microsoft.com/office/drawing/2014/main" id="{83691CCF-8F08-47F0-8CC2-BC612A73C8DF}"/>
               </a:ext>
             </a:extLst>
           </p:cNvPr>
@@ -3859,7 +3859,7 @@
           <p:cNvPr id="2" name="">
             <a:extLst xmlns:a="http://schemas.openxmlformats.org/drawingml/2006/main">
               <a:ext uri="{FF2B5EF4-FFF2-40B4-BE49-F238E27FC236}">
-                <a16:creationId xmlns:a16="http://schemas.microsoft.com/office/drawing/2014/main" id="{C1B11233-D1D2-48EE-9677-941606E19B8D}"/>
+                <a16:creationId xmlns:a16="http://schemas.microsoft.com/office/drawing/2014/main" id="{18BB1E3F-60CE-402D-84E6-598E69F5FF74}"/>
               </a:ext>
             </a:extLst>
           </p:cNvPr>
@@ -3916,7 +3916,7 @@
           <p:cNvPr id="3" name="">
             <a:extLst xmlns:a="http://schemas.openxmlformats.org/drawingml/2006/main">
               <a:ext uri="{FF2B5EF4-FFF2-40B4-BE49-F238E27FC236}">
-                <a16:creationId xmlns:a16="http://schemas.microsoft.com/office/drawing/2014/main" id="{E7B45E39-4BD6-4136-AD8F-52B7E90DFC76}"/>
+                <a16:creationId xmlns:a16="http://schemas.microsoft.com/office/drawing/2014/main" id="{CC6BAC2E-DC4C-470F-A09F-13CDFE0A3383}"/>
               </a:ext>
             </a:extLst>
           </p:cNvPr>
@@ -3973,7 +3973,7 @@
           <p:cNvPr id="4" name="">
             <a:extLst xmlns:a="http://schemas.openxmlformats.org/drawingml/2006/main">
               <a:ext uri="{FF2B5EF4-FFF2-40B4-BE49-F238E27FC236}">
-                <a16:creationId xmlns:a16="http://schemas.microsoft.com/office/drawing/2014/main" id="{D5F5AD67-7C1A-4AEE-A7F3-1596A433B4DC}"/>
+                <a16:creationId xmlns:a16="http://schemas.microsoft.com/office/drawing/2014/main" id="{2609E7D6-F3A2-4E42-BB96-659D279EF4AD}"/>
               </a:ext>
             </a:extLst>
           </p:cNvPr>
@@ -4032,7 +4032,7 @@
           <p:cNvPr id="5" name="">
             <a:extLst xmlns:a="http://schemas.openxmlformats.org/drawingml/2006/main">
               <a:ext uri="{FF2B5EF4-FFF2-40B4-BE49-F238E27FC236}">
-                <a16:creationId xmlns:a16="http://schemas.microsoft.com/office/drawing/2014/main" id="{8DEB93D9-5A88-470E-BE24-D3134F4C18AB}"/>
+                <a16:creationId xmlns:a16="http://schemas.microsoft.com/office/drawing/2014/main" id="{E54A3AD0-DEBF-44B1-B55A-1030701022C4}"/>
               </a:ext>
             </a:extLst>
           </p:cNvPr>
@@ -4091,7 +4091,7 @@
           <p:cNvPr id="6" name="">
             <a:extLst xmlns:a="http://schemas.openxmlformats.org/drawingml/2006/main">
               <a:ext uri="{FF2B5EF4-FFF2-40B4-BE49-F238E27FC236}">
-                <a16:creationId xmlns:a16="http://schemas.microsoft.com/office/drawing/2014/main" id="{66E782F2-19AD-46B2-8675-5BB6E514B7FE}"/>
+                <a16:creationId xmlns:a16="http://schemas.microsoft.com/office/drawing/2014/main" id="{B8B3B5F2-BCA2-404A-A730-46B919E03792}"/>
               </a:ext>
             </a:extLst>
           </p:cNvPr>
@@ -4223,7 +4223,7 @@
           <p:cNvPr id="9" name="">
             <a:extLst xmlns:a="http://schemas.openxmlformats.org/drawingml/2006/main">
               <a:ext uri="{FF2B5EF4-FFF2-40B4-BE49-F238E27FC236}">
-                <a16:creationId xmlns:a16="http://schemas.microsoft.com/office/drawing/2014/main" id="{78A2AF01-FDDE-4710-B916-9952F56C3019}"/>
+                <a16:creationId xmlns:a16="http://schemas.microsoft.com/office/drawing/2014/main" id="{102C9BEA-837F-4A11-9B0B-8D3BDAB501C8}"/>
               </a:ext>
             </a:extLst>
           </p:cNvPr>
@@ -4305,7 +4305,7 @@
           <p:cNvPr id="10" name="">
             <a:extLst xmlns:a="http://schemas.openxmlformats.org/drawingml/2006/main">
               <a:ext uri="{FF2B5EF4-FFF2-40B4-BE49-F238E27FC236}">
-                <a16:creationId xmlns:a16="http://schemas.microsoft.com/office/drawing/2014/main" id="{09299C8B-9F0C-4384-8388-FDC4927D923D}"/>
+                <a16:creationId xmlns:a16="http://schemas.microsoft.com/office/drawing/2014/main" id="{21E7F9F0-4BDF-4156-9343-45B2CD778894}"/>
               </a:ext>
             </a:extLst>
           </p:cNvPr>
@@ -4387,7 +4387,7 @@
           <p:cNvPr id="11" name="">
             <a:extLst xmlns:a="http://schemas.openxmlformats.org/drawingml/2006/main">
               <a:ext uri="{FF2B5EF4-FFF2-40B4-BE49-F238E27FC236}">
-                <a16:creationId xmlns:a16="http://schemas.microsoft.com/office/drawing/2014/main" id="{C08C2988-044B-455F-8FEF-3FFA1CF64DD4}"/>
+                <a16:creationId xmlns:a16="http://schemas.microsoft.com/office/drawing/2014/main" id="{D1E3452F-522B-48AE-BF3A-7EF43B39996C}"/>
               </a:ext>
             </a:extLst>
           </p:cNvPr>
@@ -4469,7 +4469,7 @@
           <p:cNvPr id="12" name="">
             <a:extLst xmlns:a="http://schemas.openxmlformats.org/drawingml/2006/main">
               <a:ext uri="{FF2B5EF4-FFF2-40B4-BE49-F238E27FC236}">
-                <a16:creationId xmlns:a16="http://schemas.microsoft.com/office/drawing/2014/main" id="{27B940E5-B2B2-4D52-B53F-20E8370C0CFF}"/>
+                <a16:creationId xmlns:a16="http://schemas.microsoft.com/office/drawing/2014/main" id="{065CA170-3ADA-4EAA-9299-C235887E98B9}"/>
               </a:ext>
             </a:extLst>
           </p:cNvPr>
@@ -4651,7 +4651,7 @@
           <p:cNvPr id="17" name="">
             <a:extLst xmlns:a="http://schemas.openxmlformats.org/drawingml/2006/main">
               <a:ext uri="{FF2B5EF4-FFF2-40B4-BE49-F238E27FC236}">
-                <a16:creationId xmlns:a16="http://schemas.microsoft.com/office/drawing/2014/main" id="{C24A2D5E-35DE-49F1-A246-7DDF27694D34}"/>
+                <a16:creationId xmlns:a16="http://schemas.microsoft.com/office/drawing/2014/main" id="{C3900878-DAED-47F6-BE84-CC2310AA5EBC}"/>
               </a:ext>
             </a:extLst>
           </p:cNvPr>
@@ -4706,7 +4706,7 @@
     </p:spTree>
     <p:extLst>
       <p:ext uri="{BB962C8B-B14F-4D97-AF65-F5344CB8AC3E}">
-        <p14:creationId xmlns:p14="http://schemas.microsoft.com/office/powerpoint/2010/main" val="319783159"/>
+        <p14:creationId xmlns:p14="http://schemas.microsoft.com/office/powerpoint/2010/main" val="1660134843"/>
       </p:ext>
     </p:extLst>
   </p:cSld>
@@ -4737,7 +4737,7 @@
           <p:cNvPr id="13" name="">
             <a:extLst xmlns:a="http://schemas.openxmlformats.org/drawingml/2006/main">
               <a:ext uri="{FF2B5EF4-FFF2-40B4-BE49-F238E27FC236}">
-                <a16:creationId xmlns:a16="http://schemas.microsoft.com/office/drawing/2014/main" id="{7F4429DD-801C-4817-A0EE-6D4919CB9492}"/>
+                <a16:creationId xmlns:a16="http://schemas.microsoft.com/office/drawing/2014/main" id="{EEFD8424-3923-4523-97B5-A59B503A0644}"/>
               </a:ext>
             </a:extLst>
           </p:cNvPr>
@@ -4794,7 +4794,7 @@
           <p:cNvPr id="2" name="">
             <a:extLst xmlns:a="http://schemas.openxmlformats.org/drawingml/2006/main">
               <a:ext uri="{FF2B5EF4-FFF2-40B4-BE49-F238E27FC236}">
-                <a16:creationId xmlns:a16="http://schemas.microsoft.com/office/drawing/2014/main" id="{BA2E7862-6B0F-4CB9-BB0C-71ED193BEAC5}"/>
+                <a16:creationId xmlns:a16="http://schemas.microsoft.com/office/drawing/2014/main" id="{4D067546-17A2-4BAC-BE22-519666445B95}"/>
               </a:ext>
             </a:extLst>
           </p:cNvPr>
@@ -4851,7 +4851,7 @@
           <p:cNvPr id="3" name="">
             <a:extLst xmlns:a="http://schemas.openxmlformats.org/drawingml/2006/main">
               <a:ext uri="{FF2B5EF4-FFF2-40B4-BE49-F238E27FC236}">
-                <a16:creationId xmlns:a16="http://schemas.microsoft.com/office/drawing/2014/main" id="{E0D87D7C-3687-4A7D-A363-6DD42B2D47EB}"/>
+                <a16:creationId xmlns:a16="http://schemas.microsoft.com/office/drawing/2014/main" id="{3EEF97CA-FA01-4193-A199-6C95C8CCD056}"/>
               </a:ext>
             </a:extLst>
           </p:cNvPr>
@@ -4908,7 +4908,7 @@
           <p:cNvPr id="4" name="">
             <a:extLst xmlns:a="http://schemas.openxmlformats.org/drawingml/2006/main">
               <a:ext uri="{FF2B5EF4-FFF2-40B4-BE49-F238E27FC236}">
-                <a16:creationId xmlns:a16="http://schemas.microsoft.com/office/drawing/2014/main" id="{1AF1EE8A-05D1-4E70-914C-55CEA9FD14B4}"/>
+                <a16:creationId xmlns:a16="http://schemas.microsoft.com/office/drawing/2014/main" id="{5B8F4E23-04DE-4F04-9090-54AE0E0C58E6}"/>
               </a:ext>
             </a:extLst>
           </p:cNvPr>
@@ -4965,7 +4965,7 @@
           <p:cNvPr id="5" name="">
             <a:extLst xmlns:a="http://schemas.openxmlformats.org/drawingml/2006/main">
               <a:ext uri="{FF2B5EF4-FFF2-40B4-BE49-F238E27FC236}">
-                <a16:creationId xmlns:a16="http://schemas.microsoft.com/office/drawing/2014/main" id="{69AF795C-C558-4684-AF69-CB299E04CA12}"/>
+                <a16:creationId xmlns:a16="http://schemas.microsoft.com/office/drawing/2014/main" id="{20FFFE58-E7EE-458F-B56F-3774EBC7560C}"/>
               </a:ext>
             </a:extLst>
           </p:cNvPr>
@@ -5022,7 +5022,7 @@
           <p:cNvPr id="6" name="">
             <a:extLst xmlns:a="http://schemas.openxmlformats.org/drawingml/2006/main">
               <a:ext uri="{FF2B5EF4-FFF2-40B4-BE49-F238E27FC236}">
-                <a16:creationId xmlns:a16="http://schemas.microsoft.com/office/drawing/2014/main" id="{C9FB99C3-16A4-4821-8F7A-264175272B40}"/>
+                <a16:creationId xmlns:a16="http://schemas.microsoft.com/office/drawing/2014/main" id="{B73F7FC8-B05F-493A-86ED-4C6B9A02D46F}"/>
               </a:ext>
             </a:extLst>
           </p:cNvPr>
@@ -5079,7 +5079,7 @@
           <p:cNvPr id="7" name="">
             <a:extLst xmlns:a="http://schemas.openxmlformats.org/drawingml/2006/main">
               <a:ext uri="{FF2B5EF4-FFF2-40B4-BE49-F238E27FC236}">
-                <a16:creationId xmlns:a16="http://schemas.microsoft.com/office/drawing/2014/main" id="{61BD8ECE-5CF1-4EFC-9E58-28E0623CDDFA}"/>
+                <a16:creationId xmlns:a16="http://schemas.microsoft.com/office/drawing/2014/main" id="{CD74B450-9492-4A42-AE3A-414E050D2805}"/>
               </a:ext>
             </a:extLst>
           </p:cNvPr>
@@ -5136,7 +5136,7 @@
           <p:cNvPr id="8" name="">
             <a:extLst xmlns:a="http://schemas.openxmlformats.org/drawingml/2006/main">
               <a:ext uri="{FF2B5EF4-FFF2-40B4-BE49-F238E27FC236}">
-                <a16:creationId xmlns:a16="http://schemas.microsoft.com/office/drawing/2014/main" id="{0F12A45C-0CE7-407D-BC11-8A00F15BC5C1}"/>
+                <a16:creationId xmlns:a16="http://schemas.microsoft.com/office/drawing/2014/main" id="{3312F7CE-834E-48F7-8428-16BEF154D7CC}"/>
               </a:ext>
             </a:extLst>
           </p:cNvPr>
@@ -5193,7 +5193,7 @@
           <p:cNvPr id="9" name="">
             <a:extLst xmlns:a="http://schemas.openxmlformats.org/drawingml/2006/main">
               <a:ext uri="{FF2B5EF4-FFF2-40B4-BE49-F238E27FC236}">
-                <a16:creationId xmlns:a16="http://schemas.microsoft.com/office/drawing/2014/main" id="{AB31FB1C-6F87-47A7-8E09-7087E12C8A8E}"/>
+                <a16:creationId xmlns:a16="http://schemas.microsoft.com/office/drawing/2014/main" id="{F25CD6BA-4912-4821-A109-E583B606F9D6}"/>
               </a:ext>
             </a:extLst>
           </p:cNvPr>
@@ -5250,7 +5250,7 @@
           <p:cNvPr id="10" name="">
             <a:extLst xmlns:a="http://schemas.openxmlformats.org/drawingml/2006/main">
               <a:ext uri="{FF2B5EF4-FFF2-40B4-BE49-F238E27FC236}">
-                <a16:creationId xmlns:a16="http://schemas.microsoft.com/office/drawing/2014/main" id="{D56B6253-9ADF-4ED5-890A-5C416125FC3E}"/>
+                <a16:creationId xmlns:a16="http://schemas.microsoft.com/office/drawing/2014/main" id="{4429F6D8-38DF-4170-B9FD-E1EB34D651A2}"/>
               </a:ext>
             </a:extLst>
           </p:cNvPr>
@@ -5307,7 +5307,7 @@
           <p:cNvPr id="11" name="">
             <a:extLst xmlns:a="http://schemas.openxmlformats.org/drawingml/2006/main">
               <a:ext uri="{FF2B5EF4-FFF2-40B4-BE49-F238E27FC236}">
-                <a16:creationId xmlns:a16="http://schemas.microsoft.com/office/drawing/2014/main" id="{DA2427AA-0876-44B9-90D5-68CE153311FF}"/>
+                <a16:creationId xmlns:a16="http://schemas.microsoft.com/office/drawing/2014/main" id="{50131F0B-6463-485A-8517-339423275E81}"/>
               </a:ext>
             </a:extLst>
           </p:cNvPr>
@@ -5364,7 +5364,7 @@
           <p:cNvPr id="12" name="">
             <a:extLst xmlns:a="http://schemas.openxmlformats.org/drawingml/2006/main">
               <a:ext uri="{FF2B5EF4-FFF2-40B4-BE49-F238E27FC236}">
-                <a16:creationId xmlns:a16="http://schemas.microsoft.com/office/drawing/2014/main" id="{FD4F768D-A718-44D5-80AF-0E634920051A}"/>
+                <a16:creationId xmlns:a16="http://schemas.microsoft.com/office/drawing/2014/main" id="{8412C2FE-DAD8-49FD-A856-65224908FB7F}"/>
               </a:ext>
             </a:extLst>
           </p:cNvPr>
@@ -5419,7 +5419,7 @@
     </p:spTree>
     <p:extLst>
       <p:ext uri="{BB962C8B-B14F-4D97-AF65-F5344CB8AC3E}">
-        <p14:creationId xmlns:p14="http://schemas.microsoft.com/office/powerpoint/2010/main" val="639709576"/>
+        <p14:creationId xmlns:p14="http://schemas.microsoft.com/office/powerpoint/2010/main" val="2045194429"/>
       </p:ext>
     </p:extLst>
   </p:cSld>
@@ -5450,7 +5450,7 @@
           <p:cNvPr id="10" name="">
             <a:extLst xmlns:a="http://schemas.openxmlformats.org/drawingml/2006/main">
               <a:ext uri="{FF2B5EF4-FFF2-40B4-BE49-F238E27FC236}">
-                <a16:creationId xmlns:a16="http://schemas.microsoft.com/office/drawing/2014/main" id="{4A84B8A8-CB28-42D3-8AD3-C7F70758D69F}"/>
+                <a16:creationId xmlns:a16="http://schemas.microsoft.com/office/drawing/2014/main" id="{710013EF-410D-4C0C-AF4C-0C9EAC60889E}"/>
               </a:ext>
             </a:extLst>
           </p:cNvPr>
@@ -5507,7 +5507,7 @@
           <p:cNvPr id="2" name="">
             <a:extLst xmlns:a="http://schemas.openxmlformats.org/drawingml/2006/main">
               <a:ext uri="{FF2B5EF4-FFF2-40B4-BE49-F238E27FC236}">
-                <a16:creationId xmlns:a16="http://schemas.microsoft.com/office/drawing/2014/main" id="{FE2E0E13-6152-4ACC-9A44-7DBB64D91DA1}"/>
+                <a16:creationId xmlns:a16="http://schemas.microsoft.com/office/drawing/2014/main" id="{FDB34E7A-6CC3-4AD9-B17C-70E5C4F049A8}"/>
               </a:ext>
             </a:extLst>
           </p:cNvPr>
@@ -5564,7 +5564,7 @@
           <p:cNvPr id="3" name="">
             <a:extLst xmlns:a="http://schemas.openxmlformats.org/drawingml/2006/main">
               <a:ext uri="{FF2B5EF4-FFF2-40B4-BE49-F238E27FC236}">
-                <a16:creationId xmlns:a16="http://schemas.microsoft.com/office/drawing/2014/main" id="{B4C2F5DF-D012-40E3-8D77-22E1BE2AD78F}"/>
+                <a16:creationId xmlns:a16="http://schemas.microsoft.com/office/drawing/2014/main" id="{DF28DE67-CB04-4AC6-875C-03FD8146713A}"/>
               </a:ext>
             </a:extLst>
           </p:cNvPr>
@@ -5621,7 +5621,7 @@
           <p:cNvPr id="4" name="">
             <a:extLst xmlns:a="http://schemas.openxmlformats.org/drawingml/2006/main">
               <a:ext uri="{FF2B5EF4-FFF2-40B4-BE49-F238E27FC236}">
-                <a16:creationId xmlns:a16="http://schemas.microsoft.com/office/drawing/2014/main" id="{A629C173-0868-4D1D-A1F2-2F3F1CE09E34}"/>
+                <a16:creationId xmlns:a16="http://schemas.microsoft.com/office/drawing/2014/main" id="{7BEB94DE-71E4-4A73-B2B1-CB2B1D2185E8}"/>
               </a:ext>
             </a:extLst>
           </p:cNvPr>
@@ -5678,7 +5678,7 @@
           <p:cNvPr id="5" name="">
             <a:extLst xmlns:a="http://schemas.openxmlformats.org/drawingml/2006/main">
               <a:ext uri="{FF2B5EF4-FFF2-40B4-BE49-F238E27FC236}">
-                <a16:creationId xmlns:a16="http://schemas.microsoft.com/office/drawing/2014/main" id="{696134DF-DAFE-44AA-B9A8-F4A029F69F4C}"/>
+                <a16:creationId xmlns:a16="http://schemas.microsoft.com/office/drawing/2014/main" id="{696E2632-A787-466B-9AB6-FEE119ABEF12}"/>
               </a:ext>
             </a:extLst>
           </p:cNvPr>
@@ -5735,7 +5735,7 @@
           <p:cNvPr id="6" name="">
             <a:extLst xmlns:a="http://schemas.openxmlformats.org/drawingml/2006/main">
               <a:ext uri="{FF2B5EF4-FFF2-40B4-BE49-F238E27FC236}">
-                <a16:creationId xmlns:a16="http://schemas.microsoft.com/office/drawing/2014/main" id="{83E60FB6-FD27-44CC-BAA2-5CDEDFF74052}"/>
+                <a16:creationId xmlns:a16="http://schemas.microsoft.com/office/drawing/2014/main" id="{3ECCC527-CF2B-4C09-8204-93413CE2FED3}"/>
               </a:ext>
             </a:extLst>
           </p:cNvPr>
@@ -5792,7 +5792,7 @@
           <p:cNvPr id="7" name="">
             <a:extLst xmlns:a="http://schemas.openxmlformats.org/drawingml/2006/main">
               <a:ext uri="{FF2B5EF4-FFF2-40B4-BE49-F238E27FC236}">
-                <a16:creationId xmlns:a16="http://schemas.microsoft.com/office/drawing/2014/main" id="{88C86709-2BD6-4D93-957C-2FA92BDECF6E}"/>
+                <a16:creationId xmlns:a16="http://schemas.microsoft.com/office/drawing/2014/main" id="{393407B2-553A-4B5A-B072-D605E392D4B1}"/>
               </a:ext>
             </a:extLst>
           </p:cNvPr>
@@ -5849,7 +5849,7 @@
           <p:cNvPr id="8" name="">
             <a:extLst xmlns:a="http://schemas.openxmlformats.org/drawingml/2006/main">
               <a:ext uri="{FF2B5EF4-FFF2-40B4-BE49-F238E27FC236}">
-                <a16:creationId xmlns:a16="http://schemas.microsoft.com/office/drawing/2014/main" id="{045BEE34-8ED6-468C-A021-E31BFAC11009}"/>
+                <a16:creationId xmlns:a16="http://schemas.microsoft.com/office/drawing/2014/main" id="{0AA58DE6-F4E0-47C0-9003-FFEF0DDD8D8F}"/>
               </a:ext>
             </a:extLst>
           </p:cNvPr>
@@ -5906,7 +5906,7 @@
           <p:cNvPr id="9" name="">
             <a:extLst xmlns:a="http://schemas.openxmlformats.org/drawingml/2006/main">
               <a:ext uri="{FF2B5EF4-FFF2-40B4-BE49-F238E27FC236}">
-                <a16:creationId xmlns:a16="http://schemas.microsoft.com/office/drawing/2014/main" id="{D5718B00-E19C-49C9-AFB8-527742B3C3CD}"/>
+                <a16:creationId xmlns:a16="http://schemas.microsoft.com/office/drawing/2014/main" id="{66907F25-837C-4E80-B2A3-F26F7F8A3362}"/>
               </a:ext>
             </a:extLst>
           </p:cNvPr>
@@ -5961,7 +5961,7 @@
     </p:spTree>
     <p:extLst>
       <p:ext uri="{BB962C8B-B14F-4D97-AF65-F5344CB8AC3E}">
-        <p14:creationId xmlns:p14="http://schemas.microsoft.com/office/powerpoint/2010/main" val="659788068"/>
+        <p14:creationId xmlns:p14="http://schemas.microsoft.com/office/powerpoint/2010/main" val="976673857"/>
       </p:ext>
     </p:extLst>
   </p:cSld>
@@ -5992,7 +5992,7 @@
           <p:cNvPr id="9" name="">
             <a:extLst xmlns:a="http://schemas.openxmlformats.org/drawingml/2006/main">
               <a:ext uri="{FF2B5EF4-FFF2-40B4-BE49-F238E27FC236}">
-                <a16:creationId xmlns:a16="http://schemas.microsoft.com/office/drawing/2014/main" id="{8EDA7E63-5568-4325-B2BE-B48E5BA9F150}"/>
+                <a16:creationId xmlns:a16="http://schemas.microsoft.com/office/drawing/2014/main" id="{DEC07094-D89B-482E-A7CA-FF21C795C2C1}"/>
               </a:ext>
             </a:extLst>
           </p:cNvPr>
@@ -6049,7 +6049,7 @@
           <p:cNvPr id="2" name="">
             <a:extLst xmlns:a="http://schemas.openxmlformats.org/drawingml/2006/main">
               <a:ext uri="{FF2B5EF4-FFF2-40B4-BE49-F238E27FC236}">
-                <a16:creationId xmlns:a16="http://schemas.microsoft.com/office/drawing/2014/main" id="{5C8DD938-F4F5-4F7A-B352-9F42BDDBBDAF}"/>
+                <a16:creationId xmlns:a16="http://schemas.microsoft.com/office/drawing/2014/main" id="{C94E4269-5ED3-4F02-8A60-566A1DEA7765}"/>
               </a:ext>
             </a:extLst>
           </p:cNvPr>
@@ -6106,7 +6106,7 @@
           <p:cNvPr id="3" name="">
             <a:extLst xmlns:a="http://schemas.openxmlformats.org/drawingml/2006/main">
               <a:ext uri="{FF2B5EF4-FFF2-40B4-BE49-F238E27FC236}">
-                <a16:creationId xmlns:a16="http://schemas.microsoft.com/office/drawing/2014/main" id="{3DB948E7-5EB1-47AC-92D8-A36E4DD567FB}"/>
+                <a16:creationId xmlns:a16="http://schemas.microsoft.com/office/drawing/2014/main" id="{E0D9BA62-9479-4EB0-8FF7-EC460CE88706}"/>
               </a:ext>
             </a:extLst>
           </p:cNvPr>
@@ -6163,7 +6163,7 @@
           <p:cNvPr id="4" name="">
             <a:extLst xmlns:a="http://schemas.openxmlformats.org/drawingml/2006/main">
               <a:ext uri="{FF2B5EF4-FFF2-40B4-BE49-F238E27FC236}">
-                <a16:creationId xmlns:a16="http://schemas.microsoft.com/office/drawing/2014/main" id="{5673E5C6-1994-4108-ACB6-1C100630F84D}"/>
+                <a16:creationId xmlns:a16="http://schemas.microsoft.com/office/drawing/2014/main" id="{B5F8EFD2-1365-4AA1-ACA7-7CE272CA04B5}"/>
               </a:ext>
             </a:extLst>
           </p:cNvPr>
@@ -6220,7 +6220,7 @@
           <p:cNvPr id="5" name="">
             <a:extLst xmlns:a="http://schemas.openxmlformats.org/drawingml/2006/main">
               <a:ext uri="{FF2B5EF4-FFF2-40B4-BE49-F238E27FC236}">
-                <a16:creationId xmlns:a16="http://schemas.microsoft.com/office/drawing/2014/main" id="{2F49E712-AC24-43B8-8C4F-6637FF122D74}"/>
+                <a16:creationId xmlns:a16="http://schemas.microsoft.com/office/drawing/2014/main" id="{A2986A82-3D9E-4911-86AF-A4E0130FC309}"/>
               </a:ext>
             </a:extLst>
           </p:cNvPr>
@@ -6277,7 +6277,7 @@
           <p:cNvPr id="6" name="">
             <a:extLst xmlns:a="http://schemas.openxmlformats.org/drawingml/2006/main">
               <a:ext uri="{FF2B5EF4-FFF2-40B4-BE49-F238E27FC236}">
-                <a16:creationId xmlns:a16="http://schemas.microsoft.com/office/drawing/2014/main" id="{E93F42AC-EE2A-4501-85B8-09F35C707532}"/>
+                <a16:creationId xmlns:a16="http://schemas.microsoft.com/office/drawing/2014/main" id="{6E7C30D6-514D-4CF8-9CFC-EBD739C0E271}"/>
               </a:ext>
             </a:extLst>
           </p:cNvPr>
@@ -6380,7 +6380,7 @@
           <p:cNvPr id="7" name="">
             <a:extLst xmlns:a="http://schemas.openxmlformats.org/drawingml/2006/main">
               <a:ext uri="{FF2B5EF4-FFF2-40B4-BE49-F238E27FC236}">
-                <a16:creationId xmlns:a16="http://schemas.microsoft.com/office/drawing/2014/main" id="{E8D964D0-1ECE-41F0-94C2-8A800CD951B3}"/>
+                <a16:creationId xmlns:a16="http://schemas.microsoft.com/office/drawing/2014/main" id="{79453864-36DE-40AB-B419-6481840F21C2}"/>
               </a:ext>
             </a:extLst>
           </p:cNvPr>
@@ -6437,7 +6437,7 @@
           <p:cNvPr id="8" name="">
             <a:extLst xmlns:a="http://schemas.openxmlformats.org/drawingml/2006/main">
               <a:ext uri="{FF2B5EF4-FFF2-40B4-BE49-F238E27FC236}">
-                <a16:creationId xmlns:a16="http://schemas.microsoft.com/office/drawing/2014/main" id="{FB79AD0E-FBF7-4BD1-964F-67A92C6A21E9}"/>
+                <a16:creationId xmlns:a16="http://schemas.microsoft.com/office/drawing/2014/main" id="{F11E4B64-37AE-435E-9364-AB15B65E72E2}"/>
               </a:ext>
             </a:extLst>
           </p:cNvPr>
@@ -6492,7 +6492,7 @@
     </p:spTree>
     <p:extLst>
       <p:ext uri="{BB962C8B-B14F-4D97-AF65-F5344CB8AC3E}">
-        <p14:creationId xmlns:p14="http://schemas.microsoft.com/office/powerpoint/2010/main" val="425917999"/>
+        <p14:creationId xmlns:p14="http://schemas.microsoft.com/office/powerpoint/2010/main" val="242676379"/>
       </p:ext>
     </p:extLst>
   </p:cSld>
@@ -6523,7 +6523,7 @@
           <p:cNvPr id="8" name="">
             <a:extLst xmlns:a="http://schemas.openxmlformats.org/drawingml/2006/main">
               <a:ext uri="{FF2B5EF4-FFF2-40B4-BE49-F238E27FC236}">
-                <a16:creationId xmlns:a16="http://schemas.microsoft.com/office/drawing/2014/main" id="{0FA3865E-1BEB-40F0-9C62-8BBC4AA7CD27}"/>
+                <a16:creationId xmlns:a16="http://schemas.microsoft.com/office/drawing/2014/main" id="{CE428859-D15E-4F4C-B1D8-F30CB7C41FE3}"/>
               </a:ext>
             </a:extLst>
           </p:cNvPr>
@@ -6580,7 +6580,7 @@
           <p:cNvPr id="2" name="">
             <a:extLst xmlns:a="http://schemas.openxmlformats.org/drawingml/2006/main">
               <a:ext uri="{FF2B5EF4-FFF2-40B4-BE49-F238E27FC236}">
-                <a16:creationId xmlns:a16="http://schemas.microsoft.com/office/drawing/2014/main" id="{159D8467-B779-4A08-9D1E-821BDA60F23F}"/>
+                <a16:creationId xmlns:a16="http://schemas.microsoft.com/office/drawing/2014/main" id="{A1094ADC-14AE-4EC5-9DD0-FE541CA21EDE}"/>
               </a:ext>
             </a:extLst>
           </p:cNvPr>
@@ -6637,7 +6637,7 @@
           <p:cNvPr id="3" name="">
             <a:extLst xmlns:a="http://schemas.openxmlformats.org/drawingml/2006/main">
               <a:ext uri="{FF2B5EF4-FFF2-40B4-BE49-F238E27FC236}">
-                <a16:creationId xmlns:a16="http://schemas.microsoft.com/office/drawing/2014/main" id="{4EE183D5-311C-40A6-8A59-8262DD2F7287}"/>
+                <a16:creationId xmlns:a16="http://schemas.microsoft.com/office/drawing/2014/main" id="{6936F8B5-3213-47FB-8730-7D11A8EE9143}"/>
               </a:ext>
             </a:extLst>
           </p:cNvPr>
@@ -6698,7 +6698,7 @@
           <p:nvPr/>
         </p:nvPicPr>
         <p:blipFill>
-          <a:blip xmlns:r="http://schemas.openxmlformats.org/officeDocument/2006/relationships" xmlns:a="http://schemas.openxmlformats.org/drawingml/2006/main" r:embed="R6442064c14994162"/>
+          <a:blip xmlns:r="http://schemas.openxmlformats.org/officeDocument/2006/relationships" xmlns:a="http://schemas.openxmlformats.org/drawingml/2006/main" r:embed="Re0a254c00ffe47a5"/>
           <a:stretch xmlns:a="http://schemas.openxmlformats.org/drawingml/2006/main"/>
         </p:blipFill>
         <p:spPr>
@@ -6716,7 +6716,7 @@
           <p:cNvPr id="5" name="">
             <a:extLst xmlns:a="http://schemas.openxmlformats.org/drawingml/2006/main">
               <a:ext uri="{FF2B5EF4-FFF2-40B4-BE49-F238E27FC236}">
-                <a16:creationId xmlns:a16="http://schemas.microsoft.com/office/drawing/2014/main" id="{D89A598D-9057-49AB-8DDE-3944E58DC314}"/>
+                <a16:creationId xmlns:a16="http://schemas.microsoft.com/office/drawing/2014/main" id="{D2F54B1C-FBF8-4A6D-A6B7-C4184B487FFD}"/>
               </a:ext>
             </a:extLst>
           </p:cNvPr>
@@ -6773,7 +6773,7 @@
           <p:cNvPr id="6" name="">
             <a:extLst xmlns:a="http://schemas.openxmlformats.org/drawingml/2006/main">
               <a:ext uri="{FF2B5EF4-FFF2-40B4-BE49-F238E27FC236}">
-                <a16:creationId xmlns:a16="http://schemas.microsoft.com/office/drawing/2014/main" id="{DF461F3A-54EB-4F62-8FC2-A3BBAEF30E3A}"/>
+                <a16:creationId xmlns:a16="http://schemas.microsoft.com/office/drawing/2014/main" id="{8050D6B2-2DBA-421C-A58A-6E517DCACAB1}"/>
               </a:ext>
             </a:extLst>
           </p:cNvPr>
@@ -6899,7 +6899,7 @@
           <p:cNvPr id="7" name="">
             <a:extLst xmlns:a="http://schemas.openxmlformats.org/drawingml/2006/main">
               <a:ext uri="{FF2B5EF4-FFF2-40B4-BE49-F238E27FC236}">
-                <a16:creationId xmlns:a16="http://schemas.microsoft.com/office/drawing/2014/main" id="{C23CE9E6-071C-4D59-B41A-E91534FB7B4F}"/>
+                <a16:creationId xmlns:a16="http://schemas.microsoft.com/office/drawing/2014/main" id="{4AE74A63-120D-4217-ADAF-4FE7B0FDB4B4}"/>
               </a:ext>
             </a:extLst>
           </p:cNvPr>
@@ -6954,7 +6954,7 @@
     </p:spTree>
     <p:extLst>
       <p:ext uri="{BB962C8B-B14F-4D97-AF65-F5344CB8AC3E}">
-        <p14:creationId xmlns:p14="http://schemas.microsoft.com/office/powerpoint/2010/main" val="1804413354"/>
+        <p14:creationId xmlns:p14="http://schemas.microsoft.com/office/powerpoint/2010/main" val="462327647"/>
       </p:ext>
     </p:extLst>
   </p:cSld>
@@ -6985,7 +6985,7 @@
           <p:cNvPr id="8" name="">
             <a:extLst xmlns:a="http://schemas.openxmlformats.org/drawingml/2006/main">
               <a:ext uri="{FF2B5EF4-FFF2-40B4-BE49-F238E27FC236}">
-                <a16:creationId xmlns:a16="http://schemas.microsoft.com/office/drawing/2014/main" id="{F5DCC59B-6D9C-4B85-8B80-F376EC9D697E}"/>
+                <a16:creationId xmlns:a16="http://schemas.microsoft.com/office/drawing/2014/main" id="{6B936D3A-9087-428E-A788-5A6CA76DD586}"/>
               </a:ext>
             </a:extLst>
           </p:cNvPr>
@@ -7042,7 +7042,7 @@
           <p:cNvPr id="2" name="">
             <a:extLst xmlns:a="http://schemas.openxmlformats.org/drawingml/2006/main">
               <a:ext uri="{FF2B5EF4-FFF2-40B4-BE49-F238E27FC236}">
-                <a16:creationId xmlns:a16="http://schemas.microsoft.com/office/drawing/2014/main" id="{23D00F5D-396B-45C6-AF12-0951C2ACAF55}"/>
+                <a16:creationId xmlns:a16="http://schemas.microsoft.com/office/drawing/2014/main" id="{644E187B-09C5-413D-B978-BA30F158C3B5}"/>
               </a:ext>
             </a:extLst>
           </p:cNvPr>
@@ -7099,7 +7099,7 @@
           <p:cNvPr id="3" name="">
             <a:extLst xmlns:a="http://schemas.openxmlformats.org/drawingml/2006/main">
               <a:ext uri="{FF2B5EF4-FFF2-40B4-BE49-F238E27FC236}">
-                <a16:creationId xmlns:a16="http://schemas.microsoft.com/office/drawing/2014/main" id="{579ED0DA-B7BA-464D-A879-77605467BC56}"/>
+                <a16:creationId xmlns:a16="http://schemas.microsoft.com/office/drawing/2014/main" id="{7ADC511D-D6EA-4ED1-B3C8-7026D74604CB}"/>
               </a:ext>
             </a:extLst>
           </p:cNvPr>
@@ -7156,7 +7156,7 @@
           <p:cNvPr id="4" name="">
             <a:extLst xmlns:a="http://schemas.openxmlformats.org/drawingml/2006/main">
               <a:ext uri="{FF2B5EF4-FFF2-40B4-BE49-F238E27FC236}">
-                <a16:creationId xmlns:a16="http://schemas.microsoft.com/office/drawing/2014/main" id="{87DBE2C9-D1A0-4F54-BA6E-A4BDA58036A4}"/>
+                <a16:creationId xmlns:a16="http://schemas.microsoft.com/office/drawing/2014/main" id="{62C8EDC4-5311-47D6-ACBF-99189B3AC4E8}"/>
               </a:ext>
             </a:extLst>
           </p:cNvPr>
@@ -7213,7 +7213,7 @@
           <p:cNvPr id="5" name="">
             <a:extLst xmlns:a="http://schemas.openxmlformats.org/drawingml/2006/main">
               <a:ext uri="{FF2B5EF4-FFF2-40B4-BE49-F238E27FC236}">
-                <a16:creationId xmlns:a16="http://schemas.microsoft.com/office/drawing/2014/main" id="{358FD445-E80A-41BC-86D8-8CD27F2D5D1E}"/>
+                <a16:creationId xmlns:a16="http://schemas.microsoft.com/office/drawing/2014/main" id="{B7BCA758-FE62-484F-8021-B587EB29E026}"/>
               </a:ext>
             </a:extLst>
           </p:cNvPr>
@@ -7270,7 +7270,7 @@
           <p:cNvPr id="6" name="">
             <a:extLst xmlns:a="http://schemas.openxmlformats.org/drawingml/2006/main">
               <a:ext uri="{FF2B5EF4-FFF2-40B4-BE49-F238E27FC236}">
-                <a16:creationId xmlns:a16="http://schemas.microsoft.com/office/drawing/2014/main" id="{4AF1DEEE-80F4-4A09-A106-66AA6F232FF2}"/>
+                <a16:creationId xmlns:a16="http://schemas.microsoft.com/office/drawing/2014/main" id="{9881561C-F958-42BF-B8F5-BB73F59ADED3}"/>
               </a:ext>
             </a:extLst>
           </p:cNvPr>
@@ -7327,7 +7327,7 @@
           <p:cNvPr id="7" name="">
             <a:extLst xmlns:a="http://schemas.openxmlformats.org/drawingml/2006/main">
               <a:ext uri="{FF2B5EF4-FFF2-40B4-BE49-F238E27FC236}">
-                <a16:creationId xmlns:a16="http://schemas.microsoft.com/office/drawing/2014/main" id="{B2B457FE-1AEC-4644-A095-999632716AC6}"/>
+                <a16:creationId xmlns:a16="http://schemas.microsoft.com/office/drawing/2014/main" id="{5A2EA8DF-E52A-49D3-8A9E-DD6E9F200604}"/>
               </a:ext>
             </a:extLst>
           </p:cNvPr>
@@ -7382,7 +7382,7 @@
     </p:spTree>
     <p:extLst>
       <p:ext uri="{BB962C8B-B14F-4D97-AF65-F5344CB8AC3E}">
-        <p14:creationId xmlns:p14="http://schemas.microsoft.com/office/powerpoint/2010/main" val="474739165"/>
+        <p14:creationId xmlns:p14="http://schemas.microsoft.com/office/powerpoint/2010/main" val="746081650"/>
       </p:ext>
     </p:extLst>
   </p:cSld>

</xml_diff>